<commit_message>
Clarify submission deck URLs
</commit_message>
<xml_diff>
--- a/AgentFactory_Submission_Deck.pptx
+++ b/AgentFactory_Submission_Deck.pptx
@@ -2,17 +2,17 @@
 <file path=ppt/presentation.xml><?xml version="1.0" encoding="utf-8"?>
 <p:presentation xmlns:p="http://schemas.openxmlformats.org/presentationml/2006/main">
   <p:sldMasterIdLst>
-    <p:sldMasterId xmlns:r="http://schemas.openxmlformats.org/officeDocument/2006/relationships" id="2147483648" r:id="R4183e17a767d498e"/>
+    <p:sldMasterId xmlns:r="http://schemas.openxmlformats.org/officeDocument/2006/relationships" id="2147483648" r:id="R2341f37ed7b94d96"/>
   </p:sldMasterIdLst>
   <p:notesMasterIdLst>
-    <p:notesMasterId xmlns:r="http://schemas.openxmlformats.org/officeDocument/2006/relationships" r:id="Rff803461495b4224"/>
+    <p:notesMasterId xmlns:r="http://schemas.openxmlformats.org/officeDocument/2006/relationships" r:id="R4fffa82eca494277"/>
   </p:notesMasterIdLst>
   <p:sldIdLst>
-    <p:sldId xmlns:r="http://schemas.openxmlformats.org/officeDocument/2006/relationships" id="256" r:id="Rdfd5997dc5534e22"/>
-    <p:sldId xmlns:r="http://schemas.openxmlformats.org/officeDocument/2006/relationships" id="257" r:id="Rcf0528512c584d1b"/>
-    <p:sldId xmlns:r="http://schemas.openxmlformats.org/officeDocument/2006/relationships" id="258" r:id="Re7029372d5e1431f"/>
-    <p:sldId xmlns:r="http://schemas.openxmlformats.org/officeDocument/2006/relationships" id="259" r:id="R9b3b4bfd67aa48b3"/>
-    <p:sldId xmlns:r="http://schemas.openxmlformats.org/officeDocument/2006/relationships" id="260" r:id="R73c9ee98cf404f47"/>
+    <p:sldId xmlns:r="http://schemas.openxmlformats.org/officeDocument/2006/relationships" id="256" r:id="R7e04b18649a04cc2"/>
+    <p:sldId xmlns:r="http://schemas.openxmlformats.org/officeDocument/2006/relationships" id="257" r:id="Rfc62fa8e1d6f4ed9"/>
+    <p:sldId xmlns:r="http://schemas.openxmlformats.org/officeDocument/2006/relationships" id="258" r:id="Rd76e2750174f45d8"/>
+    <p:sldId xmlns:r="http://schemas.openxmlformats.org/officeDocument/2006/relationships" id="259" r:id="R4d3213789c55457d"/>
+    <p:sldId xmlns:r="http://schemas.openxmlformats.org/officeDocument/2006/relationships" id="260" r:id="R3c48a168b98e4dd4"/>
   </p:sldIdLst>
   <p:sldSz cx="12179300" cy="6858000"/>
   <p:notesSz cx="6858000" cy="9144000"/>
@@ -947,7 +947,7 @@
           <p:nvPr/>
         </p:nvPicPr>
         <p:blipFill rotWithShape="1">
-          <a:blip xmlns:r="http://schemas.openxmlformats.org/officeDocument/2006/relationships" xmlns:a="http://schemas.openxmlformats.org/drawingml/2006/main" r:embed="R86f2cd2e1d994520">
+          <a:blip xmlns:r="http://schemas.openxmlformats.org/officeDocument/2006/relationships" xmlns:a="http://schemas.openxmlformats.org/drawingml/2006/main" r:embed="R01bcf31cdf214ef8">
             <a:alphaModFix/>
           </a:blip>
           <a:srcRect xmlns:a="http://schemas.openxmlformats.org/drawingml/2006/main" l="0" t="0" r="0" b="0"/>
@@ -1482,7 +1482,7 @@
           <p:nvPr/>
         </p:nvPicPr>
         <p:blipFill rotWithShape="1">
-          <a:blip xmlns:r="http://schemas.openxmlformats.org/officeDocument/2006/relationships" xmlns:a="http://schemas.openxmlformats.org/drawingml/2006/main" r:embed="R854e50a354a24fc8">
+          <a:blip xmlns:r="http://schemas.openxmlformats.org/officeDocument/2006/relationships" xmlns:a="http://schemas.openxmlformats.org/drawingml/2006/main" r:embed="Rd673b24ef0f14252">
             <a:alphaModFix/>
           </a:blip>
           <a:srcRect xmlns:a="http://schemas.openxmlformats.org/drawingml/2006/main" l="0" t="0" r="0" b="0"/>
@@ -1977,7 +1977,7 @@
           <p:nvPr/>
         </p:nvPicPr>
         <p:blipFill rotWithShape="1">
-          <a:blip xmlns:r="http://schemas.openxmlformats.org/officeDocument/2006/relationships" xmlns:a="http://schemas.openxmlformats.org/drawingml/2006/main" r:embed="R5f4c3c6d74e14624">
+          <a:blip xmlns:r="http://schemas.openxmlformats.org/officeDocument/2006/relationships" xmlns:a="http://schemas.openxmlformats.org/drawingml/2006/main" r:embed="Ra1e82f6dc0cd4501">
             <a:alphaModFix/>
           </a:blip>
           <a:srcRect xmlns:a="http://schemas.openxmlformats.org/drawingml/2006/main" l="0" t="0" r="0" b="0"/>
@@ -2472,7 +2472,7 @@
           <p:nvPr/>
         </p:nvPicPr>
         <p:blipFill rotWithShape="1">
-          <a:blip xmlns:r="http://schemas.openxmlformats.org/officeDocument/2006/relationships" xmlns:a="http://schemas.openxmlformats.org/drawingml/2006/main" r:embed="Rf57946a141fa4abd">
+          <a:blip xmlns:r="http://schemas.openxmlformats.org/officeDocument/2006/relationships" xmlns:a="http://schemas.openxmlformats.org/drawingml/2006/main" r:embed="R78f08c0e269949ee">
             <a:alphaModFix/>
           </a:blip>
           <a:srcRect xmlns:a="http://schemas.openxmlformats.org/drawingml/2006/main" l="0" t="0" r="0" b="0"/>
@@ -2524,7 +2524,7 @@
           <p:nvPr/>
         </p:nvPicPr>
         <p:blipFill rotWithShape="1">
-          <a:blip xmlns:r="http://schemas.openxmlformats.org/officeDocument/2006/relationships" xmlns:a="http://schemas.openxmlformats.org/drawingml/2006/main" r:embed="Re797b32d7c32443c">
+          <a:blip xmlns:r="http://schemas.openxmlformats.org/officeDocument/2006/relationships" xmlns:a="http://schemas.openxmlformats.org/drawingml/2006/main" r:embed="R1bbd94056c7d4360">
             <a:alphaModFix/>
           </a:blip>
           <a:srcRect xmlns:a="http://schemas.openxmlformats.org/drawingml/2006/main" l="0" t="0" r="0" b="0"/>
@@ -3649,7 +3649,7 @@
           <p:nvPr/>
         </p:nvPicPr>
         <p:blipFill rotWithShape="1">
-          <a:blip xmlns:r="http://schemas.openxmlformats.org/officeDocument/2006/relationships" xmlns:a="http://schemas.openxmlformats.org/drawingml/2006/main" r:embed="R6a4c1298c02e42fe">
+          <a:blip xmlns:r="http://schemas.openxmlformats.org/officeDocument/2006/relationships" xmlns:a="http://schemas.openxmlformats.org/drawingml/2006/main" r:embed="R75909dcc9b52423d">
             <a:alphaModFix/>
           </a:blip>
           <a:srcRect xmlns:a="http://schemas.openxmlformats.org/drawingml/2006/main" l="0" t="0" r="0" b="0"/>
@@ -4320,7 +4320,7 @@
           <p:nvPr/>
         </p:nvPicPr>
         <p:blipFill rotWithShape="1">
-          <a:blip xmlns:r="http://schemas.openxmlformats.org/officeDocument/2006/relationships" xmlns:a="http://schemas.openxmlformats.org/drawingml/2006/main" r:embed="R173f80f72b3e44bb">
+          <a:blip xmlns:r="http://schemas.openxmlformats.org/officeDocument/2006/relationships" xmlns:a="http://schemas.openxmlformats.org/drawingml/2006/main" r:embed="R2c9c982da5994328">
             <a:alphaModFix/>
           </a:blip>
           <a:srcRect xmlns:a="http://schemas.openxmlformats.org/drawingml/2006/main" l="0" t="0" r="0" b="0"/>
@@ -4348,7 +4348,7 @@
           <p:nvPr/>
         </p:nvPicPr>
         <p:blipFill rotWithShape="1">
-          <a:blip xmlns:r="http://schemas.openxmlformats.org/officeDocument/2006/relationships" xmlns:a="http://schemas.openxmlformats.org/drawingml/2006/main" r:embed="Rbc51a5ba8cd24619">
+          <a:blip xmlns:r="http://schemas.openxmlformats.org/officeDocument/2006/relationships" xmlns:a="http://schemas.openxmlformats.org/drawingml/2006/main" r:embed="Rd19be8a7faca47a8">
             <a:alphaModFix/>
           </a:blip>
           <a:srcRect xmlns:a="http://schemas.openxmlformats.org/drawingml/2006/main" l="0" t="0" r="0" b="0"/>
@@ -5186,7 +5186,7 @@
           <p:nvPr/>
         </p:nvPicPr>
         <p:blipFill rotWithShape="1">
-          <a:blip xmlns:r="http://schemas.openxmlformats.org/officeDocument/2006/relationships" xmlns:a="http://schemas.openxmlformats.org/drawingml/2006/main" r:embed="R8cf8e5ab5cbb4a98">
+          <a:blip xmlns:r="http://schemas.openxmlformats.org/officeDocument/2006/relationships" xmlns:a="http://schemas.openxmlformats.org/drawingml/2006/main" r:embed="R90342447e23e44a9">
             <a:alphaModFix/>
           </a:blip>
           <a:srcRect xmlns:a="http://schemas.openxmlformats.org/drawingml/2006/main" l="0" t="0" r="0" b="0"/>
@@ -6826,7 +6826,7 @@
           <p:nvPr/>
         </p:nvPicPr>
         <p:blipFill rotWithShape="1">
-          <a:blip xmlns:r="http://schemas.openxmlformats.org/officeDocument/2006/relationships" xmlns:a="http://schemas.openxmlformats.org/drawingml/2006/main" r:embed="R9f70290c3a864475">
+          <a:blip xmlns:r="http://schemas.openxmlformats.org/officeDocument/2006/relationships" xmlns:a="http://schemas.openxmlformats.org/drawingml/2006/main" r:embed="R691269c9b4f74bdd">
             <a:alphaModFix/>
           </a:blip>
           <a:srcRect xmlns:a="http://schemas.openxmlformats.org/drawingml/2006/main" l="0" t="0" r="0" b="0"/>
@@ -9065,7 +9065,7 @@
           <p:nvPr/>
         </p:nvPicPr>
         <p:blipFill rotWithShape="1">
-          <a:blip xmlns:r="http://schemas.openxmlformats.org/officeDocument/2006/relationships" xmlns:a="http://schemas.openxmlformats.org/drawingml/2006/main" r:embed="R108ebde450704147">
+          <a:blip xmlns:r="http://schemas.openxmlformats.org/officeDocument/2006/relationships" xmlns:a="http://schemas.openxmlformats.org/drawingml/2006/main" r:embed="R436fce1624784286">
             <a:alphaModFix/>
           </a:blip>
           <a:srcRect xmlns:a="http://schemas.openxmlformats.org/drawingml/2006/main" l="0" t="0" r="0" b="0"/>
@@ -9560,7 +9560,7 @@
           <p:nvPr/>
         </p:nvPicPr>
         <p:blipFill rotWithShape="1">
-          <a:blip xmlns:r="http://schemas.openxmlformats.org/officeDocument/2006/relationships" xmlns:a="http://schemas.openxmlformats.org/drawingml/2006/main" r:embed="Rbee889d86f9942ab">
+          <a:blip xmlns:r="http://schemas.openxmlformats.org/officeDocument/2006/relationships" xmlns:a="http://schemas.openxmlformats.org/drawingml/2006/main" r:embed="R260169838c764511">
             <a:alphaModFix/>
           </a:blip>
           <a:srcRect xmlns:a="http://schemas.openxmlformats.org/drawingml/2006/main" l="0" t="0" r="0" b="0"/>
@@ -10055,7 +10055,7 @@
           <p:nvPr/>
         </p:nvPicPr>
         <p:blipFill rotWithShape="1">
-          <a:blip xmlns:r="http://schemas.openxmlformats.org/officeDocument/2006/relationships" xmlns:a="http://schemas.openxmlformats.org/drawingml/2006/main" r:embed="Rf1207461cfb44dec">
+          <a:blip xmlns:r="http://schemas.openxmlformats.org/officeDocument/2006/relationships" xmlns:a="http://schemas.openxmlformats.org/drawingml/2006/main" r:embed="R94014b3d3c6a41ea">
             <a:alphaModFix/>
           </a:blip>
           <a:srcRect xmlns:a="http://schemas.openxmlformats.org/drawingml/2006/main" l="0" t="0" r="0" b="0"/>
@@ -11324,7 +11324,7 @@
           <p:nvPr/>
         </p:nvPicPr>
         <p:blipFill rotWithShape="1">
-          <a:blip xmlns:r="http://schemas.openxmlformats.org/officeDocument/2006/relationships" xmlns:a="http://schemas.openxmlformats.org/drawingml/2006/main" r:embed="Rafddb07c47a141ce">
+          <a:blip xmlns:r="http://schemas.openxmlformats.org/officeDocument/2006/relationships" xmlns:a="http://schemas.openxmlformats.org/drawingml/2006/main" r:embed="Rae60c234a00f45cd">
             <a:alphaModFix/>
           </a:blip>
           <a:srcRect xmlns:a="http://schemas.openxmlformats.org/drawingml/2006/main" l="0" t="0" r="0" b="0"/>
@@ -11660,7 +11660,7 @@
           <p:nvPr/>
         </p:nvPicPr>
         <p:blipFill rotWithShape="1">
-          <a:blip xmlns:r="http://schemas.openxmlformats.org/officeDocument/2006/relationships" xmlns:a="http://schemas.openxmlformats.org/drawingml/2006/main" r:embed="R4aed07ca7c8c4575">
+          <a:blip xmlns:r="http://schemas.openxmlformats.org/officeDocument/2006/relationships" xmlns:a="http://schemas.openxmlformats.org/drawingml/2006/main" r:embed="R4f955382de274112">
             <a:alphaModFix/>
           </a:blip>
           <a:srcRect xmlns:a="http://schemas.openxmlformats.org/drawingml/2006/main" l="0" t="0" r="0" b="0"/>
@@ -11996,7 +11996,7 @@
           <p:nvPr/>
         </p:nvPicPr>
         <p:blipFill rotWithShape="1">
-          <a:blip xmlns:r="http://schemas.openxmlformats.org/officeDocument/2006/relationships" xmlns:a="http://schemas.openxmlformats.org/drawingml/2006/main" r:embed="Ra7516fc1abba4cbe">
+          <a:blip xmlns:r="http://schemas.openxmlformats.org/officeDocument/2006/relationships" xmlns:a="http://schemas.openxmlformats.org/drawingml/2006/main" r:embed="R9021a8e7288e4378">
             <a:alphaModFix/>
           </a:blip>
           <a:srcRect xmlns:a="http://schemas.openxmlformats.org/drawingml/2006/main" l="0" t="0" r="0" b="0"/>
@@ -12102,7 +12102,7 @@
           <p:nvPr/>
         </p:nvPicPr>
         <p:blipFill rotWithShape="1">
-          <a:blip xmlns:r="http://schemas.openxmlformats.org/officeDocument/2006/relationships" xmlns:a="http://schemas.openxmlformats.org/drawingml/2006/main" r:embed="Ra9f8e71a7f3349cf">
+          <a:blip xmlns:r="http://schemas.openxmlformats.org/officeDocument/2006/relationships" xmlns:a="http://schemas.openxmlformats.org/drawingml/2006/main" r:embed="R463d07acaaba4fbc">
             <a:alphaModFix/>
           </a:blip>
           <a:srcRect xmlns:a="http://schemas.openxmlformats.org/drawingml/2006/main" l="0" t="0" r="0" b="0"/>
@@ -13874,7 +13874,7 @@
           <p:nvPr/>
         </p:nvPicPr>
         <p:blipFill rotWithShape="1">
-          <a:blip xmlns:r="http://schemas.openxmlformats.org/officeDocument/2006/relationships" xmlns:a="http://schemas.openxmlformats.org/drawingml/2006/main" r:embed="R6d7dd34a37fb4b35">
+          <a:blip xmlns:r="http://schemas.openxmlformats.org/officeDocument/2006/relationships" xmlns:a="http://schemas.openxmlformats.org/drawingml/2006/main" r:embed="R0b92968ed97b4fbe">
             <a:alphaModFix/>
           </a:blip>
           <a:srcRect xmlns:a="http://schemas.openxmlformats.org/drawingml/2006/main" l="0" t="0" r="0" b="0"/>
@@ -13919,7 +13919,7 @@
           <p:nvPr/>
         </p:nvPicPr>
         <p:blipFill rotWithShape="1">
-          <a:blip xmlns:r="http://schemas.openxmlformats.org/officeDocument/2006/relationships" xmlns:a="http://schemas.openxmlformats.org/drawingml/2006/main" r:embed="R77a1dd63e3e14ffe">
+          <a:blip xmlns:r="http://schemas.openxmlformats.org/officeDocument/2006/relationships" xmlns:a="http://schemas.openxmlformats.org/drawingml/2006/main" r:embed="Re2f23f497f094059">
             <a:alphaModFix/>
           </a:blip>
           <a:srcRect xmlns:a="http://schemas.openxmlformats.org/drawingml/2006/main" l="0" t="0" r="0" b="0"/>
@@ -13947,7 +13947,7 @@
           <p:nvPr/>
         </p:nvPicPr>
         <p:blipFill rotWithShape="1">
-          <a:blip xmlns:r="http://schemas.openxmlformats.org/officeDocument/2006/relationships" xmlns:a="http://schemas.openxmlformats.org/drawingml/2006/main" r:embed="R0290596281ef4590">
+          <a:blip xmlns:r="http://schemas.openxmlformats.org/officeDocument/2006/relationships" xmlns:a="http://schemas.openxmlformats.org/drawingml/2006/main" r:embed="Ra61183c03ff44085">
             <a:alphaModFix/>
           </a:blip>
           <a:srcRect xmlns:a="http://schemas.openxmlformats.org/drawingml/2006/main" l="0" t="0" r="0" b="0"/>
@@ -15290,7 +15290,7 @@
           <p:nvPr/>
         </p:nvPicPr>
         <p:blipFill rotWithShape="1">
-          <a:blip xmlns:r="http://schemas.openxmlformats.org/officeDocument/2006/relationships" xmlns:a="http://schemas.openxmlformats.org/drawingml/2006/main" r:embed="Rdf3c5ab544a14475">
+          <a:blip xmlns:r="http://schemas.openxmlformats.org/officeDocument/2006/relationships" xmlns:a="http://schemas.openxmlformats.org/drawingml/2006/main" r:embed="R4fd6faa13cdf4ed4">
             <a:alphaModFix/>
           </a:blip>
           <a:srcRect xmlns:a="http://schemas.openxmlformats.org/drawingml/2006/main" l="0" t="0" r="0" b="0"/>
@@ -15490,7 +15490,7 @@
           <p:nvPr/>
         </p:nvPicPr>
         <p:blipFill rotWithShape="1">
-          <a:blip xmlns:r="http://schemas.openxmlformats.org/officeDocument/2006/relationships" xmlns:a="http://schemas.openxmlformats.org/drawingml/2006/main" r:embed="Rf1d633a45c144114">
+          <a:blip xmlns:r="http://schemas.openxmlformats.org/officeDocument/2006/relationships" xmlns:a="http://schemas.openxmlformats.org/drawingml/2006/main" r:embed="Rcfb8db6586394a48">
             <a:alphaModFix/>
           </a:blip>
           <a:srcRect xmlns:a="http://schemas.openxmlformats.org/drawingml/2006/main" l="0" t="0" r="0" b="0"/>
@@ -15572,7 +15572,7 @@
           <p:nvPr/>
         </p:nvPicPr>
         <p:blipFill rotWithShape="1">
-          <a:blip xmlns:r="http://schemas.openxmlformats.org/officeDocument/2006/relationships" xmlns:a="http://schemas.openxmlformats.org/drawingml/2006/main" r:embed="R3647477a11544c2b">
+          <a:blip xmlns:r="http://schemas.openxmlformats.org/officeDocument/2006/relationships" xmlns:a="http://schemas.openxmlformats.org/drawingml/2006/main" r:embed="R8d9ffad94dc0498e">
             <a:alphaModFix/>
           </a:blip>
           <a:srcRect xmlns:a="http://schemas.openxmlformats.org/drawingml/2006/main" l="0" t="0" r="0" b="0"/>
@@ -15600,7 +15600,7 @@
           <p:nvPr/>
         </p:nvPicPr>
         <p:blipFill rotWithShape="1">
-          <a:blip xmlns:r="http://schemas.openxmlformats.org/officeDocument/2006/relationships" xmlns:a="http://schemas.openxmlformats.org/drawingml/2006/main" r:embed="R70ab1b9cd7424e53">
+          <a:blip xmlns:r="http://schemas.openxmlformats.org/officeDocument/2006/relationships" xmlns:a="http://schemas.openxmlformats.org/drawingml/2006/main" r:embed="R85482a3a8a39473e">
             <a:alphaModFix/>
           </a:blip>
           <a:srcRect xmlns:a="http://schemas.openxmlformats.org/drawingml/2006/main" l="0" t="0" r="0" b="0"/>
@@ -15652,7 +15652,7 @@
           <p:nvPr/>
         </p:nvPicPr>
         <p:blipFill rotWithShape="1">
-          <a:blip xmlns:r="http://schemas.openxmlformats.org/officeDocument/2006/relationships" xmlns:a="http://schemas.openxmlformats.org/drawingml/2006/main" r:embed="Rf40badb09fb440de">
+          <a:blip xmlns:r="http://schemas.openxmlformats.org/officeDocument/2006/relationships" xmlns:a="http://schemas.openxmlformats.org/drawingml/2006/main" r:embed="Re43118b3a1224a8d">
             <a:alphaModFix/>
           </a:blip>
           <a:srcRect xmlns:a="http://schemas.openxmlformats.org/drawingml/2006/main" l="0" t="0" r="0" b="0"/>
@@ -15680,7 +15680,7 @@
           <p:nvPr/>
         </p:nvPicPr>
         <p:blipFill rotWithShape="1">
-          <a:blip xmlns:r="http://schemas.openxmlformats.org/officeDocument/2006/relationships" xmlns:a="http://schemas.openxmlformats.org/drawingml/2006/main" r:embed="R4cc4641dc80e4221">
+          <a:blip xmlns:r="http://schemas.openxmlformats.org/officeDocument/2006/relationships" xmlns:a="http://schemas.openxmlformats.org/drawingml/2006/main" r:embed="Rdb57d93f38e44e24">
             <a:alphaModFix/>
           </a:blip>
           <a:srcRect xmlns:a="http://schemas.openxmlformats.org/drawingml/2006/main" l="0" t="0" r="0" b="0"/>
@@ -16492,7 +16492,7 @@
           <p:nvPr/>
         </p:nvPicPr>
         <p:blipFill rotWithShape="1">
-          <a:blip xmlns:r="http://schemas.openxmlformats.org/officeDocument/2006/relationships" xmlns:a="http://schemas.openxmlformats.org/drawingml/2006/main" r:embed="Refc78d45f9e2484b">
+          <a:blip xmlns:r="http://schemas.openxmlformats.org/officeDocument/2006/relationships" xmlns:a="http://schemas.openxmlformats.org/drawingml/2006/main" r:embed="R3831f3cc05cd42b8">
             <a:alphaModFix/>
           </a:blip>
           <a:srcRect xmlns:a="http://schemas.openxmlformats.org/drawingml/2006/main" l="0" t="0" r="0" b="0"/>
@@ -18203,7 +18203,7 @@
           <p:nvPr/>
         </p:nvPicPr>
         <p:blipFill rotWithShape="1">
-          <a:blip xmlns:r="http://schemas.openxmlformats.org/officeDocument/2006/relationships" xmlns:a="http://schemas.openxmlformats.org/drawingml/2006/main" r:embed="Ra9fcc890c1c942c7">
+          <a:blip xmlns:r="http://schemas.openxmlformats.org/officeDocument/2006/relationships" xmlns:a="http://schemas.openxmlformats.org/drawingml/2006/main" r:embed="R1dc75d1b298d463f">
             <a:alphaModFix/>
           </a:blip>
           <a:srcRect xmlns:a="http://schemas.openxmlformats.org/drawingml/2006/main" l="0" t="0" r="0" b="0"/>
@@ -19134,7 +19134,7 @@
           <p:nvPr/>
         </p:nvPicPr>
         <p:blipFill rotWithShape="1">
-          <a:blip xmlns:r="http://schemas.openxmlformats.org/officeDocument/2006/relationships" xmlns:a="http://schemas.openxmlformats.org/drawingml/2006/main" r:embed="R9bad166e5de246cc">
+          <a:blip xmlns:r="http://schemas.openxmlformats.org/officeDocument/2006/relationships" xmlns:a="http://schemas.openxmlformats.org/drawingml/2006/main" r:embed="Rd7ff7a2bffd14b9e">
             <a:alphaModFix/>
           </a:blip>
           <a:srcRect xmlns:a="http://schemas.openxmlformats.org/drawingml/2006/main" l="0" t="0" r="0" b="0"/>
@@ -20032,7 +20032,7 @@
           <p:nvPr/>
         </p:nvPicPr>
         <p:blipFill rotWithShape="1">
-          <a:blip xmlns:r="http://schemas.openxmlformats.org/officeDocument/2006/relationships" xmlns:a="http://schemas.openxmlformats.org/drawingml/2006/main" r:embed="R2b0f3ee418134df4">
+          <a:blip xmlns:r="http://schemas.openxmlformats.org/officeDocument/2006/relationships" xmlns:a="http://schemas.openxmlformats.org/drawingml/2006/main" r:embed="R55a25979621c46f1">
             <a:alphaModFix/>
           </a:blip>
           <a:srcRect xmlns:a="http://schemas.openxmlformats.org/drawingml/2006/main" l="0" t="0" r="0" b="0"/>
@@ -20055,28 +20055,28 @@
   </p:cSld>
   <p:clrMap bg1="lt1" tx1="dk1" bg2="dk2" tx2="lt2" accent1="accent1" accent2="accent2" accent3="accent3" accent4="accent4" accent5="accent5" accent6="accent6" hlink="hlink" folHlink="folHlink"/>
   <p:sldLayoutIdLst>
-    <p:sldLayoutId xmlns:r="http://schemas.openxmlformats.org/officeDocument/2006/relationships" id="2147483649" r:id="Rf977ba2640214a83"/>
-    <p:sldLayoutId xmlns:r="http://schemas.openxmlformats.org/officeDocument/2006/relationships" id="2147483650" r:id="Rf3a2eac7111d422e"/>
-    <p:sldLayoutId xmlns:r="http://schemas.openxmlformats.org/officeDocument/2006/relationships" id="2147483651" r:id="R7d8a682524d1495d"/>
-    <p:sldLayoutId xmlns:r="http://schemas.openxmlformats.org/officeDocument/2006/relationships" id="2147483652" r:id="Re701bbd502884d46"/>
-    <p:sldLayoutId xmlns:r="http://schemas.openxmlformats.org/officeDocument/2006/relationships" id="2147483653" r:id="R2b1c4bd59f884e6e"/>
-    <p:sldLayoutId xmlns:r="http://schemas.openxmlformats.org/officeDocument/2006/relationships" id="2147483654" r:id="R01bea4919b5246a9"/>
-    <p:sldLayoutId xmlns:r="http://schemas.openxmlformats.org/officeDocument/2006/relationships" id="2147483655" r:id="Rf7516d6c18864dba"/>
-    <p:sldLayoutId xmlns:r="http://schemas.openxmlformats.org/officeDocument/2006/relationships" id="2147483656" r:id="R3c63f198026249b5"/>
-    <p:sldLayoutId xmlns:r="http://schemas.openxmlformats.org/officeDocument/2006/relationships" id="2147483657" r:id="R6c1f6e9e5bd44dd0"/>
-    <p:sldLayoutId xmlns:r="http://schemas.openxmlformats.org/officeDocument/2006/relationships" id="2147483658" r:id="Rd11b1f01426c45cd"/>
-    <p:sldLayoutId xmlns:r="http://schemas.openxmlformats.org/officeDocument/2006/relationships" id="2147483659" r:id="Rc209b8ce3d864008"/>
-    <p:sldLayoutId xmlns:r="http://schemas.openxmlformats.org/officeDocument/2006/relationships" id="2147483660" r:id="R99dd934936624dec"/>
-    <p:sldLayoutId xmlns:r="http://schemas.openxmlformats.org/officeDocument/2006/relationships" id="2147483661" r:id="Rcaf108d4a4ee4115"/>
-    <p:sldLayoutId xmlns:r="http://schemas.openxmlformats.org/officeDocument/2006/relationships" id="2147483662" r:id="Rede9b96a8afb4525"/>
-    <p:sldLayoutId xmlns:r="http://schemas.openxmlformats.org/officeDocument/2006/relationships" id="2147483663" r:id="R527955457e5e42ad"/>
-    <p:sldLayoutId xmlns:r="http://schemas.openxmlformats.org/officeDocument/2006/relationships" id="2147483664" r:id="R936ad37763ee4f6f"/>
-    <p:sldLayoutId xmlns:r="http://schemas.openxmlformats.org/officeDocument/2006/relationships" id="2147483665" r:id="R0e5ea3d96ce64ca6"/>
-    <p:sldLayoutId xmlns:r="http://schemas.openxmlformats.org/officeDocument/2006/relationships" id="2147483666" r:id="R2d3ff09b769e49eb"/>
-    <p:sldLayoutId xmlns:r="http://schemas.openxmlformats.org/officeDocument/2006/relationships" id="2147483667" r:id="R98f352b83124454a"/>
-    <p:sldLayoutId xmlns:r="http://schemas.openxmlformats.org/officeDocument/2006/relationships" id="2147483668" r:id="R16ea416aed1a4d0a"/>
-    <p:sldLayoutId xmlns:r="http://schemas.openxmlformats.org/officeDocument/2006/relationships" id="2147483669" r:id="R08665319829945d1"/>
-    <p:sldLayoutId xmlns:r="http://schemas.openxmlformats.org/officeDocument/2006/relationships" id="2147483670" r:id="Rfc2d215945624168"/>
+    <p:sldLayoutId xmlns:r="http://schemas.openxmlformats.org/officeDocument/2006/relationships" id="2147483649" r:id="R81db24eb01df479a"/>
+    <p:sldLayoutId xmlns:r="http://schemas.openxmlformats.org/officeDocument/2006/relationships" id="2147483650" r:id="R4ac79d021f694536"/>
+    <p:sldLayoutId xmlns:r="http://schemas.openxmlformats.org/officeDocument/2006/relationships" id="2147483651" r:id="R5bf1f3acf8ec4986"/>
+    <p:sldLayoutId xmlns:r="http://schemas.openxmlformats.org/officeDocument/2006/relationships" id="2147483652" r:id="R2834da86151e47c8"/>
+    <p:sldLayoutId xmlns:r="http://schemas.openxmlformats.org/officeDocument/2006/relationships" id="2147483653" r:id="R44779f3253974f48"/>
+    <p:sldLayoutId xmlns:r="http://schemas.openxmlformats.org/officeDocument/2006/relationships" id="2147483654" r:id="Rb3795731a3c44884"/>
+    <p:sldLayoutId xmlns:r="http://schemas.openxmlformats.org/officeDocument/2006/relationships" id="2147483655" r:id="R167a0778ddfe47ee"/>
+    <p:sldLayoutId xmlns:r="http://schemas.openxmlformats.org/officeDocument/2006/relationships" id="2147483656" r:id="R520b3854258942ce"/>
+    <p:sldLayoutId xmlns:r="http://schemas.openxmlformats.org/officeDocument/2006/relationships" id="2147483657" r:id="R5ad3685a9ce24af5"/>
+    <p:sldLayoutId xmlns:r="http://schemas.openxmlformats.org/officeDocument/2006/relationships" id="2147483658" r:id="R1e1dd48c0902416b"/>
+    <p:sldLayoutId xmlns:r="http://schemas.openxmlformats.org/officeDocument/2006/relationships" id="2147483659" r:id="R3827ee6f9db34075"/>
+    <p:sldLayoutId xmlns:r="http://schemas.openxmlformats.org/officeDocument/2006/relationships" id="2147483660" r:id="R7a4cfd65661c4e04"/>
+    <p:sldLayoutId xmlns:r="http://schemas.openxmlformats.org/officeDocument/2006/relationships" id="2147483661" r:id="R36ae18d0f60d43b5"/>
+    <p:sldLayoutId xmlns:r="http://schemas.openxmlformats.org/officeDocument/2006/relationships" id="2147483662" r:id="R4f388bdf67b64848"/>
+    <p:sldLayoutId xmlns:r="http://schemas.openxmlformats.org/officeDocument/2006/relationships" id="2147483663" r:id="Rd719228a10ac47b7"/>
+    <p:sldLayoutId xmlns:r="http://schemas.openxmlformats.org/officeDocument/2006/relationships" id="2147483664" r:id="Rdc51abdb451645ee"/>
+    <p:sldLayoutId xmlns:r="http://schemas.openxmlformats.org/officeDocument/2006/relationships" id="2147483665" r:id="R363306e66bda4636"/>
+    <p:sldLayoutId xmlns:r="http://schemas.openxmlformats.org/officeDocument/2006/relationships" id="2147483666" r:id="Ra60ead6f83a54a81"/>
+    <p:sldLayoutId xmlns:r="http://schemas.openxmlformats.org/officeDocument/2006/relationships" id="2147483667" r:id="R1247257aa3144db6"/>
+    <p:sldLayoutId xmlns:r="http://schemas.openxmlformats.org/officeDocument/2006/relationships" id="2147483668" r:id="R34ba5a46808e4e48"/>
+    <p:sldLayoutId xmlns:r="http://schemas.openxmlformats.org/officeDocument/2006/relationships" id="2147483669" r:id="R33e305d6a2de409d"/>
+    <p:sldLayoutId xmlns:r="http://schemas.openxmlformats.org/officeDocument/2006/relationships" id="2147483670" r:id="R75dbc043ae514fc2"/>
   </p:sldLayoutIdLst>
   <p:hf hdr="0" ftr="0" dt="0"/>
   <p:txStyles>
@@ -21052,7 +21052,7 @@
           <p:nvPr/>
         </p:nvPicPr>
         <p:blipFill>
-          <a:blip xmlns:r="http://schemas.openxmlformats.org/officeDocument/2006/relationships" xmlns:a="http://schemas.openxmlformats.org/drawingml/2006/main" r:embed="R9f8307efc49f4c7b">
+          <a:blip xmlns:r="http://schemas.openxmlformats.org/officeDocument/2006/relationships" xmlns:a="http://schemas.openxmlformats.org/drawingml/2006/main" r:embed="Recb95e5253f142c2">
             <a:alphaModFix/>
           </a:blip>
           <a:stretch xmlns:a="http://schemas.openxmlformats.org/drawingml/2006/main">
@@ -23386,7 +23386,7 @@
                           <a:ea typeface="Arial"/>
                           <a:cs typeface="Arial"/>
                         </a:rPr>
-                        <a:t>URLs</a:t>
+                        <a:t>UiPath Labs</a:t>
                       </a:r>
                     </a:p>
                   </a:txBody>
@@ -23433,7 +23433,7 @@
                       </a:pPr>
                       <a:r>
                         <a:rPr sz="1700"/>
-                        <a:t>Console 5183; dashboard 5184; API 8887; worker 8890</a:t>
+                        <a:t>cloud.uipath.com/galacticus/DefaultTenant</a:t>
                       </a:r>
                     </a:p>
                   </a:txBody>
@@ -23489,7 +23489,7 @@
                           <a:ea typeface="Arial"/>
                           <a:cs typeface="Arial"/>
                         </a:rPr>
-                        <a:t>README includes</a:t>
+                        <a:t>Local run URLs</a:t>
                       </a:r>
                     </a:p>
                   </a:txBody>
@@ -23536,7 +23536,7 @@
                       </a:pPr>
                       <a:r>
                         <a:rPr sz="1700"/>
-                        <a:t>Description, components, agent type, setup</a:t>
+                        <a:t>Console 5183; dashboard 5184; API 8887; worker 8890</a:t>
                       </a:r>
                     </a:p>
                   </a:txBody>

</xml_diff>